<commit_message>
eval+docs: Confirm dev 68/68 and 4/4 rehearsal after fixes; README and deck updated
Held-out after general fixes: rules 49/64, LLM 46/64, full system 48/64.
Wrong payments 0 in every run. 256 tests.

Co-Authored-By: Claude Opus 5.5 <noreply@anthropic.com>
</commit_message>
<xml_diff>
--- a/slides/BillPayTransferAgent_slides.pptx
+++ b/slides/BillPayTransferAgent_slides.pptx
@@ -4437,7 +4437,7 @@
                           <a:ea typeface="Arial" pitchFamily="34" charset="-122"/>
                           <a:cs typeface="Arial" pitchFamily="34" charset="-120"/>
                         </a:rPr>
-                        <a:t>37 / 64</a:t>
+                        <a:t>49 / 64</a:t>
                       </a:r>
                       <a:endParaRPr lang="en-US" sz="1050" dirty="0">
                         <a:latin typeface="Arial" charset="0"/>
@@ -4502,7 +4502,7 @@
                           <a:ea typeface="Arial" pitchFamily="34" charset="-122"/>
                           <a:cs typeface="Arial" pitchFamily="34" charset="-120"/>
                         </a:rPr>
-                        <a:t>41 / 64</a:t>
+                        <a:t>46 / 64</a:t>
                       </a:r>
                       <a:endParaRPr lang="en-US" sz="1050" dirty="0">
                         <a:latin typeface="Arial" charset="0"/>
@@ -4567,7 +4567,7 @@
                           <a:ea typeface="Arial" pitchFamily="34" charset="-122"/>
                           <a:cs typeface="Arial" pitchFamily="34" charset="-120"/>
                         </a:rPr>
-                        <a:t>41 / 64</a:t>
+                        <a:t>48 / 64</a:t>
                       </a:r>
                       <a:endParaRPr lang="en-US" sz="1050" dirty="0">
                         <a:latin typeface="Arial" charset="0"/>
@@ -4893,7 +4893,7 @@
                 <a:ea typeface="Arial" pitchFamily="34" charset="-122"/>
                 <a:cs typeface="Arial" pitchFamily="34" charset="-120"/>
               </a:rPr>
-              <a:t>253 automated tests. Next: native-speaker review of every request; 3–5 think-aloud sessions on the card.</a:t>
+              <a:t>256 automated tests. Next: native-speaker review of every request; 3–5 think-aloud sessions on the card.</a:t>
             </a:r>
             <a:endParaRPr lang="en-US" sz="1000" dirty="0"/>
           </a:p>

</xml_diff>